<commit_message>
added text for decimal
</commit_message>
<xml_diff>
--- a/images/week6.pptx
+++ b/images/week6.pptx
@@ -6,6 +6,7 @@
   </p:sldMasterIdLst>
   <p:sldIdLst>
     <p:sldId id="256" r:id="rId2"/>
+    <p:sldId id="257" r:id="rId3"/>
   </p:sldIdLst>
   <p:sldSz cx="12192000" cy="6858000"/>
   <p:notesSz cx="6858000" cy="9144000"/>
@@ -3975,6 +3976,445 @@
 </p:sld>
 </file>
 
+<file path=ppt/slides/slide2.xml><?xml version="1.0" encoding="utf-8"?>
+<p:sld xmlns:a="http://schemas.openxmlformats.org/drawingml/2006/main" xmlns:r="http://schemas.openxmlformats.org/officeDocument/2006/relationships" xmlns:p="http://schemas.openxmlformats.org/presentationml/2006/main">
+  <p:cSld>
+    <p:spTree>
+      <p:nvGrpSpPr>
+        <p:cNvPr id="1" name=""/>
+        <p:cNvGrpSpPr/>
+        <p:nvPr/>
+      </p:nvGrpSpPr>
+      <p:grpSpPr>
+        <a:xfrm>
+          <a:off x="0" y="0"/>
+          <a:ext cx="0" cy="0"/>
+          <a:chOff x="0" y="0"/>
+          <a:chExt cx="0" cy="0"/>
+        </a:xfrm>
+      </p:grpSpPr>
+      <p:grpSp>
+        <p:nvGrpSpPr>
+          <p:cNvPr id="24" name="Group 23">
+            <a:extLst>
+              <a:ext uri="{FF2B5EF4-FFF2-40B4-BE49-F238E27FC236}">
+                <a16:creationId xmlns:a16="http://schemas.microsoft.com/office/drawing/2014/main" id="{90550393-9B46-AC6E-BD1A-469AF897FEA7}"/>
+              </a:ext>
+            </a:extLst>
+          </p:cNvPr>
+          <p:cNvGrpSpPr/>
+          <p:nvPr/>
+        </p:nvGrpSpPr>
+        <p:grpSpPr>
+          <a:xfrm>
+            <a:off x="2904044" y="2231424"/>
+            <a:ext cx="5407933" cy="3324829"/>
+            <a:chOff x="2904044" y="2231424"/>
+            <a:chExt cx="5407933" cy="3324829"/>
+          </a:xfrm>
+        </p:grpSpPr>
+        <p:sp>
+          <p:nvSpPr>
+            <p:cNvPr id="7" name="TextBox 6">
+              <a:extLst>
+                <a:ext uri="{FF2B5EF4-FFF2-40B4-BE49-F238E27FC236}">
+                  <a16:creationId xmlns:a16="http://schemas.microsoft.com/office/drawing/2014/main" id="{35744ED1-B68A-B845-57C5-BFDF35EC0DAE}"/>
+                </a:ext>
+              </a:extLst>
+            </p:cNvPr>
+            <p:cNvSpPr txBox="1"/>
+            <p:nvPr/>
+          </p:nvSpPr>
+          <p:spPr>
+            <a:xfrm>
+              <a:off x="2904044" y="3608172"/>
+              <a:ext cx="574196" cy="1015663"/>
+            </a:xfrm>
+            <a:prstGeom prst="rect">
+              <a:avLst/>
+            </a:prstGeom>
+            <a:noFill/>
+          </p:spPr>
+          <p:txBody>
+            <a:bodyPr wrap="none" rtlCol="0">
+              <a:spAutoFit/>
+            </a:bodyPr>
+            <a:lstStyle/>
+            <a:p>
+              <a:r>
+                <a:rPr lang="en-US" sz="6000" dirty="0"/>
+                <a:t>8</a:t>
+              </a:r>
+            </a:p>
+          </p:txBody>
+        </p:sp>
+        <p:sp>
+          <p:nvSpPr>
+            <p:cNvPr id="8" name="TextBox 7">
+              <a:extLst>
+                <a:ext uri="{FF2B5EF4-FFF2-40B4-BE49-F238E27FC236}">
+                  <a16:creationId xmlns:a16="http://schemas.microsoft.com/office/drawing/2014/main" id="{611E0C90-3F29-3CFA-3006-3AD8CE6AD7F7}"/>
+                </a:ext>
+              </a:extLst>
+            </p:cNvPr>
+            <p:cNvSpPr txBox="1"/>
+            <p:nvPr/>
+          </p:nvSpPr>
+          <p:spPr>
+            <a:xfrm>
+              <a:off x="3512118" y="3610582"/>
+              <a:ext cx="574196" cy="1015663"/>
+            </a:xfrm>
+            <a:prstGeom prst="rect">
+              <a:avLst/>
+            </a:prstGeom>
+            <a:noFill/>
+          </p:spPr>
+          <p:txBody>
+            <a:bodyPr wrap="none" rtlCol="0">
+              <a:spAutoFit/>
+            </a:bodyPr>
+            <a:lstStyle/>
+            <a:p>
+              <a:r>
+                <a:rPr lang="en-US" sz="6000" dirty="0"/>
+                <a:t>1</a:t>
+              </a:r>
+            </a:p>
+          </p:txBody>
+        </p:sp>
+        <p:sp>
+          <p:nvSpPr>
+            <p:cNvPr id="9" name="TextBox 8">
+              <a:extLst>
+                <a:ext uri="{FF2B5EF4-FFF2-40B4-BE49-F238E27FC236}">
+                  <a16:creationId xmlns:a16="http://schemas.microsoft.com/office/drawing/2014/main" id="{ADAC2B72-F76A-16BE-0B6F-0493A7A88682}"/>
+                </a:ext>
+              </a:extLst>
+            </p:cNvPr>
+            <p:cNvSpPr txBox="1"/>
+            <p:nvPr/>
+          </p:nvSpPr>
+          <p:spPr>
+            <a:xfrm>
+              <a:off x="4086314" y="3608173"/>
+              <a:ext cx="574196" cy="1015663"/>
+            </a:xfrm>
+            <a:prstGeom prst="rect">
+              <a:avLst/>
+            </a:prstGeom>
+            <a:noFill/>
+          </p:spPr>
+          <p:txBody>
+            <a:bodyPr wrap="none" rtlCol="0">
+              <a:spAutoFit/>
+            </a:bodyPr>
+            <a:lstStyle/>
+            <a:p>
+              <a:r>
+                <a:rPr lang="en-US" sz="6000" dirty="0"/>
+                <a:t>5</a:t>
+              </a:r>
+            </a:p>
+          </p:txBody>
+        </p:sp>
+        <p:sp>
+          <p:nvSpPr>
+            <p:cNvPr id="10" name="TextBox 9">
+              <a:extLst>
+                <a:ext uri="{FF2B5EF4-FFF2-40B4-BE49-F238E27FC236}">
+                  <a16:creationId xmlns:a16="http://schemas.microsoft.com/office/drawing/2014/main" id="{CF525238-DD0C-67A9-CFB5-F8EEB86B0186}"/>
+                </a:ext>
+              </a:extLst>
+            </p:cNvPr>
+            <p:cNvSpPr txBox="1"/>
+            <p:nvPr/>
+          </p:nvSpPr>
+          <p:spPr>
+            <a:xfrm>
+              <a:off x="4660510" y="3608173"/>
+              <a:ext cx="574196" cy="1015663"/>
+            </a:xfrm>
+            <a:prstGeom prst="rect">
+              <a:avLst/>
+            </a:prstGeom>
+            <a:noFill/>
+          </p:spPr>
+          <p:txBody>
+            <a:bodyPr wrap="none" rtlCol="0">
+              <a:spAutoFit/>
+            </a:bodyPr>
+            <a:lstStyle/>
+            <a:p>
+              <a:r>
+                <a:rPr lang="en-US" sz="6000" dirty="0"/>
+                <a:t>0</a:t>
+              </a:r>
+            </a:p>
+          </p:txBody>
+        </p:sp>
+        <p:sp>
+          <p:nvSpPr>
+            <p:cNvPr id="16" name="Line Callout 1 (Border and Accent Bar) 15">
+              <a:extLst>
+                <a:ext uri="{FF2B5EF4-FFF2-40B4-BE49-F238E27FC236}">
+                  <a16:creationId xmlns:a16="http://schemas.microsoft.com/office/drawing/2014/main" id="{805AA452-FAB0-6953-8200-84087507B44A}"/>
+                </a:ext>
+              </a:extLst>
+            </p:cNvPr>
+            <p:cNvSpPr/>
+            <p:nvPr/>
+          </p:nvSpPr>
+          <p:spPr>
+            <a:xfrm>
+              <a:off x="3027452" y="4901345"/>
+              <a:ext cx="1854300" cy="654908"/>
+            </a:xfrm>
+            <a:prstGeom prst="accentBorderCallout1">
+              <a:avLst>
+                <a:gd name="adj1" fmla="val 18750"/>
+                <a:gd name="adj2" fmla="val -8333"/>
+                <a:gd name="adj3" fmla="val -66326"/>
+                <a:gd name="adj4" fmla="val 8416"/>
+              </a:avLst>
+            </a:prstGeom>
+          </p:spPr>
+          <p:style>
+            <a:lnRef idx="2">
+              <a:schemeClr val="accent1">
+                <a:shade val="50000"/>
+              </a:schemeClr>
+            </a:lnRef>
+            <a:fillRef idx="1">
+              <a:schemeClr val="accent1"/>
+            </a:fillRef>
+            <a:effectRef idx="0">
+              <a:schemeClr val="accent1"/>
+            </a:effectRef>
+            <a:fontRef idx="minor">
+              <a:schemeClr val="lt1"/>
+            </a:fontRef>
+          </p:style>
+          <p:txBody>
+            <a:bodyPr rtlCol="0" anchor="ctr"/>
+            <a:lstStyle/>
+            <a:p>
+              <a:pPr algn="ctr"/>
+              <a:r>
+                <a:rPr lang="en-US" sz="1600" dirty="0"/>
+                <a:t>1</a:t>
+              </a:r>
+              <a:r>
+                <a:rPr lang="en-US" sz="1600" baseline="30000" dirty="0"/>
+                <a:t>st</a:t>
+              </a:r>
+              <a:r>
+                <a:rPr lang="en-US" sz="1600" dirty="0"/>
+                <a:t> significant digit</a:t>
+              </a:r>
+            </a:p>
+          </p:txBody>
+        </p:sp>
+        <p:sp>
+          <p:nvSpPr>
+            <p:cNvPr id="17" name="Line Callout 1 (Border and Accent Bar) 16">
+              <a:extLst>
+                <a:ext uri="{FF2B5EF4-FFF2-40B4-BE49-F238E27FC236}">
+                  <a16:creationId xmlns:a16="http://schemas.microsoft.com/office/drawing/2014/main" id="{D457A501-E58F-C6F8-CF57-FC1D83A36735}"/>
+                </a:ext>
+              </a:extLst>
+            </p:cNvPr>
+            <p:cNvSpPr/>
+            <p:nvPr/>
+          </p:nvSpPr>
+          <p:spPr>
+            <a:xfrm>
+              <a:off x="4272102" y="2231424"/>
+              <a:ext cx="1854300" cy="654908"/>
+            </a:xfrm>
+            <a:prstGeom prst="accentBorderCallout1">
+              <a:avLst>
+                <a:gd name="adj1" fmla="val 18750"/>
+                <a:gd name="adj2" fmla="val -8333"/>
+                <a:gd name="adj3" fmla="val 218580"/>
+                <a:gd name="adj4" fmla="val -27569"/>
+              </a:avLst>
+            </a:prstGeom>
+          </p:spPr>
+          <p:style>
+            <a:lnRef idx="2">
+              <a:schemeClr val="accent1">
+                <a:shade val="50000"/>
+              </a:schemeClr>
+            </a:lnRef>
+            <a:fillRef idx="1">
+              <a:schemeClr val="accent1"/>
+            </a:fillRef>
+            <a:effectRef idx="0">
+              <a:schemeClr val="accent1"/>
+            </a:effectRef>
+            <a:fontRef idx="minor">
+              <a:schemeClr val="lt1"/>
+            </a:fontRef>
+          </p:style>
+          <p:txBody>
+            <a:bodyPr rtlCol="0" anchor="ctr"/>
+            <a:lstStyle/>
+            <a:p>
+              <a:pPr algn="ctr"/>
+              <a:r>
+                <a:rPr lang="en-US" sz="1600" dirty="0"/>
+                <a:t>2</a:t>
+              </a:r>
+              <a:r>
+                <a:rPr lang="en-US" sz="1600" baseline="30000" dirty="0"/>
+                <a:t>nd</a:t>
+              </a:r>
+              <a:r>
+                <a:rPr lang="en-US" sz="1600" dirty="0"/>
+                <a:t> significant digit</a:t>
+              </a:r>
+            </a:p>
+          </p:txBody>
+        </p:sp>
+        <p:sp>
+          <p:nvSpPr>
+            <p:cNvPr id="18" name="Line Callout 1 (Border and Accent Bar) 17">
+              <a:extLst>
+                <a:ext uri="{FF2B5EF4-FFF2-40B4-BE49-F238E27FC236}">
+                  <a16:creationId xmlns:a16="http://schemas.microsoft.com/office/drawing/2014/main" id="{23AD0101-89F4-153B-D829-FC2D36C67B8B}"/>
+                </a:ext>
+              </a:extLst>
+            </p:cNvPr>
+            <p:cNvSpPr/>
+            <p:nvPr/>
+          </p:nvSpPr>
+          <p:spPr>
+            <a:xfrm>
+              <a:off x="4881752" y="3101546"/>
+              <a:ext cx="1854300" cy="654908"/>
+            </a:xfrm>
+            <a:prstGeom prst="accentBorderCallout1">
+              <a:avLst>
+                <a:gd name="adj1" fmla="val 18750"/>
+                <a:gd name="adj2" fmla="val -8333"/>
+                <a:gd name="adj3" fmla="val 97825"/>
+                <a:gd name="adj4" fmla="val -30901"/>
+              </a:avLst>
+            </a:prstGeom>
+          </p:spPr>
+          <p:style>
+            <a:lnRef idx="2">
+              <a:schemeClr val="accent1">
+                <a:shade val="50000"/>
+              </a:schemeClr>
+            </a:lnRef>
+            <a:fillRef idx="1">
+              <a:schemeClr val="accent1"/>
+            </a:fillRef>
+            <a:effectRef idx="0">
+              <a:schemeClr val="accent1"/>
+            </a:effectRef>
+            <a:fontRef idx="minor">
+              <a:schemeClr val="lt1"/>
+            </a:fontRef>
+          </p:style>
+          <p:txBody>
+            <a:bodyPr rtlCol="0" anchor="ctr"/>
+            <a:lstStyle/>
+            <a:p>
+              <a:pPr algn="ctr"/>
+              <a:r>
+                <a:rPr lang="en-US" sz="1600" dirty="0"/>
+                <a:t>3</a:t>
+              </a:r>
+              <a:r>
+                <a:rPr lang="en-US" sz="1600" baseline="30000" dirty="0"/>
+                <a:t>rd</a:t>
+              </a:r>
+              <a:r>
+                <a:rPr lang="en-US" sz="1600" dirty="0"/>
+                <a:t> significant digit</a:t>
+              </a:r>
+            </a:p>
+          </p:txBody>
+        </p:sp>
+        <p:sp>
+          <p:nvSpPr>
+            <p:cNvPr id="19" name="Line Callout 1 (Border and Accent Bar) 18">
+              <a:extLst>
+                <a:ext uri="{FF2B5EF4-FFF2-40B4-BE49-F238E27FC236}">
+                  <a16:creationId xmlns:a16="http://schemas.microsoft.com/office/drawing/2014/main" id="{B34F96F1-C160-C3DC-1ABD-CF510EE6EC04}"/>
+                </a:ext>
+              </a:extLst>
+            </p:cNvPr>
+            <p:cNvSpPr/>
+            <p:nvPr/>
+          </p:nvSpPr>
+          <p:spPr>
+            <a:xfrm>
+              <a:off x="6457677" y="3971668"/>
+              <a:ext cx="1854300" cy="654908"/>
+            </a:xfrm>
+            <a:prstGeom prst="accentBorderCallout1">
+              <a:avLst>
+                <a:gd name="adj1" fmla="val 18750"/>
+                <a:gd name="adj2" fmla="val -8333"/>
+                <a:gd name="adj3" fmla="val 48768"/>
+                <a:gd name="adj4" fmla="val -69551"/>
+              </a:avLst>
+            </a:prstGeom>
+          </p:spPr>
+          <p:style>
+            <a:lnRef idx="2">
+              <a:schemeClr val="accent1">
+                <a:shade val="50000"/>
+              </a:schemeClr>
+            </a:lnRef>
+            <a:fillRef idx="1">
+              <a:schemeClr val="accent1"/>
+            </a:fillRef>
+            <a:effectRef idx="0">
+              <a:schemeClr val="accent1"/>
+            </a:effectRef>
+            <a:fontRef idx="minor">
+              <a:schemeClr val="lt1"/>
+            </a:fontRef>
+          </p:style>
+          <p:txBody>
+            <a:bodyPr rtlCol="0" anchor="ctr"/>
+            <a:lstStyle/>
+            <a:p>
+              <a:pPr algn="ctr"/>
+              <a:r>
+                <a:rPr lang="en-US" sz="1600" dirty="0"/>
+                <a:t>4</a:t>
+              </a:r>
+              <a:r>
+                <a:rPr lang="en-US" sz="1600" baseline="30000" dirty="0"/>
+                <a:t>th</a:t>
+              </a:r>
+              <a:r>
+                <a:rPr lang="en-US" sz="1600" dirty="0"/>
+                <a:t> significant digit</a:t>
+              </a:r>
+            </a:p>
+          </p:txBody>
+        </p:sp>
+      </p:grpSp>
+    </p:spTree>
+    <p:extLst>
+      <p:ext uri="{BB962C8B-B14F-4D97-AF65-F5344CB8AC3E}">
+        <p14:creationId xmlns:p14="http://schemas.microsoft.com/office/powerpoint/2010/main" val="2485996289"/>
+      </p:ext>
+    </p:extLst>
+  </p:cSld>
+  <p:clrMapOvr>
+    <a:masterClrMapping/>
+  </p:clrMapOvr>
+</p:sld>
+</file>
+
 <file path=ppt/theme/theme1.xml><?xml version="1.0" encoding="utf-8"?>
 <a:theme xmlns:a="http://schemas.openxmlformats.org/drawingml/2006/main" name="Office Theme">
   <a:themeElements>

</xml_diff>